<commit_message>
Complete MatrixLang research artifact and numerical contracts
</commit_message>
<xml_diff>
--- a/docs/submission/MatrixLang-Deck.pptx
+++ b/docs/submission/MatrixLang-Deck.pptx
@@ -1299,7 +1299,7 @@
                 <a:latin typeface="Segoe UI"/>
                 <a:cs typeface="Segoe UI"/>
               </a:rPr>
-              <a:t>The compiler emits A * (B * C) instead. Both forms are four instructions, so the metric course projects report sees nothing at all.</a:t>
+              <a:t>Algebraic mode emits A * (B * C). Both forms are four instructions, so the metric course projects report sees nothing at all.</a:t>
             </a:r>
           </a:p>
         </p:txBody>
@@ -1732,7 +1732,7 @@
                 <a:latin typeface="Georgia"/>
                 <a:cs typeface="Georgia"/>
               </a:rPr>
-              <a:t>Where a C-subset project stops</a:t>
+              <a:t>The numerical contract decides which rewrites are legal</a:t>
             </a:r>
           </a:p>
         </p:txBody>
@@ -1776,7 +1776,7 @@
                 <a:latin typeface="Segoe UI"/>
                 <a:cs typeface="Segoe UI"/>
               </a:rPr>
-              <a:t>We measured three public compiler-design course projects. Not one of them contains an optimizer, and not one executes anything.</a:t>
+              <a:t>Strict mode is the default. Algebraic mode explicitly permits reassociation, rounding and signed-zero changes.</a:t>
             </a:r>
           </a:p>
         </p:txBody>
@@ -1820,150 +1820,44 @@
         </p:nvSpPr>
         <p:spPr>
           <a:xfrm>
-            <a:off x="711200" y="1955800"/>
-            <a:ext cx="5334000" cy="762000"/>
-          </a:xfrm>
-          <a:prstGeom prst="rect">
-            <a:avLst/>
-          </a:prstGeom>
-          <a:noFill/>
-          <a:ln>
-            <a:noFill/>
-          </a:ln>
-        </p:spPr>
-        <p:txBody>
-          <a:bodyPr wrap="square" lIns="0" tIns="0" rIns="0" bIns="0" anchor="t">
-            <a:noAutofit/>
-          </a:bodyPr>
-          <a:lstStyle/>
-          <a:p>
-            <a:pPr algn="l">
-              <a:lnSpc>
-                <a:spcPts val="5200"/>
-              </a:lnSpc>
-              <a:buNone/>
-            </a:pPr>
-            <a:r>
-              <a:rPr lang="en-US" sz="5000" dirty="0" b="1">
-                <a:solidFill>
-                  <a:srgbClr val="EF4444"/>
-                </a:solidFill>
-                <a:latin typeface="Georgia"/>
-                <a:cs typeface="Georgia"/>
-              </a:rPr>
-              <a:t>0 of 3</a:t>
-            </a:r>
-          </a:p>
-        </p:txBody>
-      </p:sp>
-      <p:sp>
-        <p:nvSpPr>
-          <p:cNvPr id="7" name="text7"/>
-          <p:cNvSpPr txBox="1"/>
-          <p:nvPr/>
-        </p:nvSpPr>
-        <p:spPr>
-          <a:xfrm>
-            <a:off x="711200" y="2692400"/>
-            <a:ext cx="5334000" cy="431800"/>
-          </a:xfrm>
-          <a:prstGeom prst="rect">
-            <a:avLst/>
-          </a:prstGeom>
-          <a:noFill/>
-          <a:ln>
-            <a:noFill/>
-          </a:ln>
-        </p:spPr>
-        <p:txBody>
-          <a:bodyPr wrap="square" lIns="0" tIns="0" rIns="0" bIns="0" anchor="t">
-            <a:noAutofit/>
-          </a:bodyPr>
-          <a:lstStyle/>
-          <a:p>
-            <a:pPr algn="l">
-              <a:lnSpc>
-                <a:spcPts val="1200"/>
-              </a:lnSpc>
-              <a:buNone/>
-            </a:pPr>
-            <a:r>
-              <a:rPr lang="en-US" sz="900" dirty="0">
-                <a:solidFill>
-                  <a:srgbClr val="8C8C8C"/>
-                </a:solidFill>
-                <a:latin typeface="Segoe UI"/>
-                <a:cs typeface="Segoe UI"/>
-              </a:rPr>
-              <a:t>baselines that reach the optimization phase, on a</a:t>
-            </a:r>
-          </a:p>
-          <a:p>
-            <a:pPr algn="l">
-              <a:lnSpc>
-                <a:spcPts val="1200"/>
-              </a:lnSpc>
-              <a:buNone/>
-            </a:pPr>
-            <a:r>
-              <a:rPr lang="en-US" sz="900" dirty="0">
-                <a:solidFill>
-                  <a:srgbClr val="8C8C8C"/>
-                </a:solidFill>
-                <a:latin typeface="Segoe UI"/>
-                <a:cs typeface="Segoe UI"/>
-              </a:rPr>
-              <a:t>search deliberately generous enough to overstate them</a:t>
-            </a:r>
-          </a:p>
-        </p:txBody>
-      </p:sp>
-      <p:sp>
-        <p:nvSpPr>
-          <p:cNvPr id="8" name="text8"/>
-          <p:cNvSpPr txBox="1"/>
-          <p:nvPr/>
-        </p:nvSpPr>
-        <p:spPr>
-          <a:xfrm>
-            <a:off x="711200" y="3530600"/>
-            <a:ext cx="5334000" cy="2997200"/>
-          </a:xfrm>
-          <a:prstGeom prst="rect">
-            <a:avLst/>
-          </a:prstGeom>
-          <a:noFill/>
-          <a:ln>
-            <a:noFill/>
-          </a:ln>
-        </p:spPr>
-        <p:txBody>
-          <a:bodyPr wrap="square" lIns="0" tIns="0" rIns="0" bIns="0" anchor="t">
-            <a:noAutofit/>
-          </a:bodyPr>
-          <a:lstStyle/>
-          <a:p>
-            <a:pPr algn="l">
-              <a:lnSpc>
-                <a:spcPts val="1562"/>
-              </a:lnSpc>
-              <a:buNone/>
-            </a:pPr>
-            <a:r>
-              <a:rPr lang="en-US" sz="1100" dirty="0">
-                <a:solidFill>
-                  <a:srgbClr val="C9C9C9"/>
-                </a:solidFill>
-                <a:latin typeface="Segoe UI"/>
-                <a:cs typeface="Segoe UI"/>
-              </a:rPr>
-              <a:t>A subset of C has two numeric types, so its type system is an enumeration with two members.</a:t>
-            </a:r>
-          </a:p>
-          <a:p>
-            <a:pPr algn="l">
-              <a:lnSpc>
-                <a:spcPts val="1491"/>
+            <a:off x="711200" y="1905000"/>
+            <a:ext cx="5207000" cy="3429000"/>
+          </a:xfrm>
+          <a:prstGeom prst="rect">
+            <a:avLst/>
+          </a:prstGeom>
+          <a:noFill/>
+          <a:ln>
+            <a:noFill/>
+          </a:ln>
+        </p:spPr>
+        <p:txBody>
+          <a:bodyPr wrap="square" lIns="0" tIns="0" rIns="0" bIns="0" anchor="t">
+            <a:noAutofit/>
+          </a:bodyPr>
+          <a:lstStyle/>
+          <a:p>
+            <a:pPr algn="l">
+              <a:lnSpc>
+                <a:spcPts val="2272"/>
+              </a:lnSpc>
+              <a:buNone/>
+            </a:pPr>
+            <a:r>
+              <a:rPr lang="en-US" sz="1600" dirty="0" b="1">
+                <a:solidFill>
+                  <a:srgbClr val="4ADE80"/>
+                </a:solidFill>
+                <a:latin typeface="Segoe UI"/>
+                <a:cs typeface="Segoe UI"/>
+              </a:rPr>
+              <a:t>Strict</a:t>
+            </a:r>
+          </a:p>
+          <a:p>
+            <a:pPr algn="l">
+              <a:lnSpc>
+                <a:spcPts val="1704"/>
               </a:lnSpc>
               <a:spcBef>
                 <a:spcPts val="900"/>
@@ -1971,20 +1865,20 @@
               <a:buNone/>
             </a:pPr>
             <a:r>
-              <a:rPr lang="en-US" sz="1050" dirty="0">
-                <a:solidFill>
-                  <a:srgbClr val="8C8C8C"/>
-                </a:solidFill>
-                <a:latin typeface="Segoe UI"/>
-                <a:cs typeface="Segoe UI"/>
-              </a:rPr>
-              <a:t>Semantic analysis becomes a comparison of two tags, and an optimizer over it has constant folding and the scalar identities, with no way to tell a cheap expression from an expensive one.</a:t>
-            </a:r>
-          </a:p>
-          <a:p>
-            <a:pPr algn="l">
-              <a:lnSpc>
-                <a:spcPts val="1491"/>
+              <a:rPr lang="en-US" sz="1200" dirty="0">
+                <a:solidFill>
+                  <a:srgbClr val="C9C9C9"/>
+                </a:solidFill>
+                <a:latin typeface="Segoe UI"/>
+                <a:cs typeface="Segoe UI"/>
+              </a:rPr>
+              <a:t>Finite constant folding, double transpose, CSE, copy propagation and dead code.</a:t>
+            </a:r>
+          </a:p>
+          <a:p>
+            <a:pPr algn="l">
+              <a:lnSpc>
+                <a:spcPts val="1562"/>
               </a:lnSpc>
               <a:spcBef>
                 <a:spcPts val="900"/>
@@ -1992,20 +1886,64 @@
               <a:buNone/>
             </a:pPr>
             <a:r>
-              <a:rPr lang="en-US" sz="1050" dirty="0">
+              <a:rPr lang="en-US" sz="1100" dirty="0">
                 <a:solidFill>
                   <a:srgbClr val="8C8C8C"/>
                 </a:solidFill>
                 <a:latin typeface="Segoe UI"/>
                 <a:cs typeface="Segoe UI"/>
               </a:rPr>
-              <a:t>The baselines are not badly built. They reach lexical analysis, parsing and the symbol table, and then run out of anything for the later phases to be about.</a:t>
-            </a:r>
-          </a:p>
-          <a:p>
-            <a:pPr algn="l">
-              <a:lnSpc>
-                <a:spcPts val="1491"/>
+              <a:t>Source product association is retained. Exact printed values are checked on the regression corpus.</a:t>
+            </a:r>
+          </a:p>
+        </p:txBody>
+      </p:sp>
+      <p:sp>
+        <p:nvSpPr>
+          <p:cNvPr id="7" name="text7"/>
+          <p:cNvSpPr txBox="1"/>
+          <p:nvPr/>
+        </p:nvSpPr>
+        <p:spPr>
+          <a:xfrm>
+            <a:off x="6426200" y="1905000"/>
+            <a:ext cx="5054600" cy="3429000"/>
+          </a:xfrm>
+          <a:prstGeom prst="rect">
+            <a:avLst/>
+          </a:prstGeom>
+          <a:noFill/>
+          <a:ln>
+            <a:noFill/>
+          </a:ln>
+        </p:spPr>
+        <p:txBody>
+          <a:bodyPr wrap="square" lIns="0" tIns="0" rIns="0" bIns="0" anchor="t">
+            <a:noAutofit/>
+          </a:bodyPr>
+          <a:lstStyle/>
+          <a:p>
+            <a:pPr algn="l">
+              <a:lnSpc>
+                <a:spcPts val="2272"/>
+              </a:lnSpc>
+              <a:buNone/>
+            </a:pPr>
+            <a:r>
+              <a:rPr lang="en-US" sz="1600" dirty="0" b="1">
+                <a:solidFill>
+                  <a:srgbClr val="EF4444"/>
+                </a:solidFill>
+                <a:latin typeface="Segoe UI"/>
+                <a:cs typeface="Segoe UI"/>
+              </a:rPr>
+              <a:t>Algebraic</a:t>
+            </a:r>
+          </a:p>
+          <a:p>
+            <a:pPr algn="l">
+              <a:lnSpc>
+                <a:spcPts val="1704"/>
               </a:lnSpc>
               <a:spcBef>
                 <a:spcPts val="900"/>
@@ -2013,771 +1951,20 @@
               <a:buNone/>
             </a:pPr>
             <a:r>
-              <a:rPr lang="en-US" sz="1050" dirty="0">
-                <a:solidFill>
-                  <a:srgbClr val="4ADE80"/>
-                </a:solidFill>
-                <a:latin typeface="Segoe UI"/>
-                <a:cs typeface="Segoe UI"/>
-              </a:rPr>
-              <a:t>The two phases the syllabus calls the centre of the subject are the two with the least to do.</a:t>
-            </a:r>
-          </a:p>
-        </p:txBody>
-      </p:sp>
-      <p:sp>
-        <p:nvSpPr>
-          <p:cNvPr id="9" name="box9"/>
-          <p:cNvSpPr txBox="1"/>
-          <p:nvPr/>
-        </p:nvSpPr>
-        <p:spPr>
-          <a:xfrm>
-            <a:off x="6680200" y="1905000"/>
-            <a:ext cx="4800600" cy="3810000"/>
-          </a:xfrm>
-          <a:prstGeom prst="roundRect">
-            <a:avLst>
-              <a:gd name="adj" fmla="val 1400"/>
-            </a:avLst>
-          </a:prstGeom>
-          <a:solidFill>
-            <a:srgbClr val="0D0D0D"/>
-          </a:solidFill>
-          <a:ln w="9525">
-            <a:solidFill>
-              <a:srgbClr val="242424"/>
-            </a:solidFill>
-          </a:ln>
-        </p:spPr>
-        <p:txBody>
-          <a:bodyPr wrap="square" lIns="101600" tIns="76200" rIns="101600" bIns="76200" anchor="t">
-            <a:noAutofit/>
-          </a:bodyPr>
-          <a:lstStyle/>
-          <a:p>
-            <a:endParaRPr lang="en-US"/>
-          </a:p>
-        </p:txBody>
-      </p:sp>
-      <p:sp>
-        <p:nvSpPr>
-          <p:cNvPr id="10" name="text10"/>
-          <p:cNvSpPr txBox="1"/>
-          <p:nvPr/>
-        </p:nvSpPr>
-        <p:spPr>
-          <a:xfrm>
-            <a:off x="6883400" y="2070100"/>
-            <a:ext cx="4394200" cy="177800"/>
-          </a:xfrm>
-          <a:prstGeom prst="rect">
-            <a:avLst/>
-          </a:prstGeom>
-          <a:noFill/>
-          <a:ln>
-            <a:noFill/>
-          </a:ln>
-        </p:spPr>
-        <p:txBody>
-          <a:bodyPr wrap="square" lIns="0" tIns="0" rIns="0" bIns="0" anchor="t">
-            <a:noAutofit/>
-          </a:bodyPr>
-          <a:lstStyle/>
-          <a:p>
-            <a:pPr algn="l">
-              <a:buNone/>
-            </a:pPr>
-            <a:r>
-              <a:rPr lang="en-US" sz="800" dirty="0" b="1" spc="130" cap="all">
-                <a:solidFill>
-                  <a:srgbClr val="4ADE80"/>
-                </a:solidFill>
-                <a:latin typeface="Segoe UI"/>
-                <a:cs typeface="Segoe UI"/>
-              </a:rPr>
-              <a:t>Phases present, of eight</a:t>
-            </a:r>
-          </a:p>
-        </p:txBody>
-      </p:sp>
-      <p:sp>
-        <p:nvSpPr>
-          <p:cNvPr id="11" name="text11"/>
-          <p:cNvSpPr txBox="1"/>
-          <p:nvPr/>
-        </p:nvSpPr>
-        <p:spPr>
-          <a:xfrm>
-            <a:off x="6908800" y="2463800"/>
-            <a:ext cx="1219200" cy="203200"/>
-          </a:xfrm>
-          <a:prstGeom prst="rect">
-            <a:avLst/>
-          </a:prstGeom>
-          <a:noFill/>
-          <a:ln>
-            <a:noFill/>
-          </a:ln>
-        </p:spPr>
-        <p:txBody>
-          <a:bodyPr wrap="square" lIns="0" tIns="0" rIns="0" bIns="0" anchor="t">
-            <a:noAutofit/>
-          </a:bodyPr>
-          <a:lstStyle/>
-          <a:p>
-            <a:pPr algn="l">
-              <a:lnSpc>
-                <a:spcPts val="1200"/>
-              </a:lnSpc>
-              <a:buNone/>
-            </a:pPr>
-            <a:r>
-              <a:rPr lang="en-US" sz="940" dirty="0" b="1">
-                <a:solidFill>
-                  <a:srgbClr val="FFFFFF"/>
-                </a:solidFill>
-                <a:latin typeface="Segoe UI"/>
-                <a:cs typeface="Segoe UI"/>
-              </a:rPr>
-              <a:t>MatrixLang</a:t>
-            </a:r>
-          </a:p>
-        </p:txBody>
-      </p:sp>
-      <p:sp>
-        <p:nvSpPr>
-          <p:cNvPr id="12" name="bar-bg12"/>
-          <p:cNvSpPr txBox="1"/>
-          <p:nvPr/>
-        </p:nvSpPr>
-        <p:spPr>
-          <a:xfrm>
-            <a:off x="8229600" y="2501900"/>
-            <a:ext cx="1905000" cy="127000"/>
-          </a:xfrm>
-          <a:prstGeom prst="rect">
-            <a:avLst/>
-          </a:prstGeom>
-          <a:solidFill>
-            <a:srgbClr val="242424"/>
-          </a:solidFill>
-          <a:ln>
-            <a:noFill/>
-          </a:ln>
-        </p:spPr>
-        <p:txBody>
-          <a:bodyPr wrap="square" lIns="101600" tIns="76200" rIns="101600" bIns="76200" anchor="t">
-            <a:noAutofit/>
-          </a:bodyPr>
-          <a:lstStyle/>
-          <a:p>
-            <a:endParaRPr lang="en-US"/>
-          </a:p>
-        </p:txBody>
-      </p:sp>
-      <p:sp>
-        <p:nvSpPr>
-          <p:cNvPr id="13" name="bar13"/>
-          <p:cNvSpPr txBox="1"/>
-          <p:nvPr/>
-        </p:nvSpPr>
-        <p:spPr>
-          <a:xfrm>
-            <a:off x="8229600" y="2501900"/>
-            <a:ext cx="1905000" cy="127000"/>
-          </a:xfrm>
-          <a:prstGeom prst="rect">
-            <a:avLst/>
-          </a:prstGeom>
-          <a:solidFill>
-            <a:srgbClr val="4ADE80"/>
-          </a:solidFill>
-          <a:ln>
-            <a:noFill/>
-          </a:ln>
-        </p:spPr>
-        <p:txBody>
-          <a:bodyPr wrap="square" lIns="101600" tIns="76200" rIns="101600" bIns="76200" anchor="t">
-            <a:noAutofit/>
-          </a:bodyPr>
-          <a:lstStyle/>
-          <a:p>
-            <a:endParaRPr lang="en-US"/>
-          </a:p>
-        </p:txBody>
-      </p:sp>
-      <p:sp>
-        <p:nvSpPr>
-          <p:cNvPr id="14" name="text14"/>
-          <p:cNvSpPr txBox="1"/>
-          <p:nvPr/>
-        </p:nvSpPr>
-        <p:spPr>
-          <a:xfrm>
-            <a:off x="10287000" y="2463800"/>
-            <a:ext cx="558800" cy="203200"/>
-          </a:xfrm>
-          <a:prstGeom prst="rect">
-            <a:avLst/>
-          </a:prstGeom>
-          <a:noFill/>
-          <a:ln>
-            <a:noFill/>
-          </a:ln>
-        </p:spPr>
-        <p:txBody>
-          <a:bodyPr wrap="square" lIns="0" tIns="0" rIns="0" bIns="0" anchor="t">
-            <a:noAutofit/>
-          </a:bodyPr>
-          <a:lstStyle/>
-          <a:p>
-            <a:pPr algn="l">
-              <a:lnSpc>
-                <a:spcPts val="1200"/>
-              </a:lnSpc>
-              <a:buNone/>
-            </a:pPr>
-            <a:r>
-              <a:rPr lang="en-US" sz="940" dirty="0" b="1">
-                <a:solidFill>
-                  <a:srgbClr val="FFFFFF"/>
-                </a:solidFill>
-                <a:latin typeface="Consolas"/>
-                <a:cs typeface="Consolas"/>
-              </a:rPr>
-              <a:t>8/8</a:t>
-            </a:r>
-          </a:p>
-        </p:txBody>
-      </p:sp>
-      <p:sp>
-        <p:nvSpPr>
-          <p:cNvPr id="15" name="text15"/>
-          <p:cNvSpPr txBox="1"/>
-          <p:nvPr/>
-        </p:nvSpPr>
-        <p:spPr>
-          <a:xfrm>
-            <a:off x="6908800" y="2895600"/>
-            <a:ext cx="1219200" cy="203200"/>
-          </a:xfrm>
-          <a:prstGeom prst="rect">
-            <a:avLst/>
-          </a:prstGeom>
-          <a:noFill/>
-          <a:ln>
-            <a:noFill/>
-          </a:ln>
-        </p:spPr>
-        <p:txBody>
-          <a:bodyPr wrap="square" lIns="0" tIns="0" rIns="0" bIns="0" anchor="t">
-            <a:noAutofit/>
-          </a:bodyPr>
-          <a:lstStyle/>
-          <a:p>
-            <a:pPr algn="l">
-              <a:lnSpc>
-                <a:spcPts val="1200"/>
-              </a:lnSpc>
-              <a:buNone/>
-            </a:pPr>
-            <a:r>
-              <a:rPr lang="en-US" sz="940" dirty="0">
+              <a:rPr lang="en-US" sz="1200" dirty="0">
                 <a:solidFill>
                   <a:srgbClr val="C9C9C9"/>
                 </a:solidFill>
                 <a:latin typeface="Segoe UI"/>
                 <a:cs typeface="Segoe UI"/>
               </a:rPr>
-              <a:t>baseline 1</a:t>
-            </a:r>
-          </a:p>
-        </p:txBody>
-      </p:sp>
-      <p:sp>
-        <p:nvSpPr>
-          <p:cNvPr id="16" name="bar-bg16"/>
-          <p:cNvSpPr txBox="1"/>
-          <p:nvPr/>
-        </p:nvSpPr>
-        <p:spPr>
-          <a:xfrm>
-            <a:off x="8229600" y="2933700"/>
-            <a:ext cx="1905000" cy="127000"/>
-          </a:xfrm>
-          <a:prstGeom prst="rect">
-            <a:avLst/>
-          </a:prstGeom>
-          <a:solidFill>
-            <a:srgbClr val="242424"/>
-          </a:solidFill>
-          <a:ln>
-            <a:noFill/>
-          </a:ln>
-        </p:spPr>
-        <p:txBody>
-          <a:bodyPr wrap="square" lIns="101600" tIns="76200" rIns="101600" bIns="76200" anchor="t">
-            <a:noAutofit/>
-          </a:bodyPr>
-          <a:lstStyle/>
-          <a:p>
-            <a:endParaRPr lang="en-US"/>
-          </a:p>
-        </p:txBody>
-      </p:sp>
-      <p:sp>
-        <p:nvSpPr>
-          <p:cNvPr id="17" name="bar17"/>
-          <p:cNvSpPr txBox="1"/>
-          <p:nvPr/>
-        </p:nvSpPr>
-        <p:spPr>
-          <a:xfrm>
-            <a:off x="8229600" y="2933700"/>
-            <a:ext cx="1190625" cy="127000"/>
-          </a:xfrm>
-          <a:prstGeom prst="rect">
-            <a:avLst/>
-          </a:prstGeom>
-          <a:solidFill>
-            <a:srgbClr val="EF4444"/>
-          </a:solidFill>
-          <a:ln>
-            <a:noFill/>
-          </a:ln>
-        </p:spPr>
-        <p:txBody>
-          <a:bodyPr wrap="square" lIns="101600" tIns="76200" rIns="101600" bIns="76200" anchor="t">
-            <a:noAutofit/>
-          </a:bodyPr>
-          <a:lstStyle/>
-          <a:p>
-            <a:endParaRPr lang="en-US"/>
-          </a:p>
-        </p:txBody>
-      </p:sp>
-      <p:sp>
-        <p:nvSpPr>
-          <p:cNvPr id="18" name="text18"/>
-          <p:cNvSpPr txBox="1"/>
-          <p:nvPr/>
-        </p:nvSpPr>
-        <p:spPr>
-          <a:xfrm>
-            <a:off x="10287000" y="2895600"/>
-            <a:ext cx="558800" cy="203200"/>
-          </a:xfrm>
-          <a:prstGeom prst="rect">
-            <a:avLst/>
-          </a:prstGeom>
-          <a:noFill/>
-          <a:ln>
-            <a:noFill/>
-          </a:ln>
-        </p:spPr>
-        <p:txBody>
-          <a:bodyPr wrap="square" lIns="0" tIns="0" rIns="0" bIns="0" anchor="t">
-            <a:noAutofit/>
-          </a:bodyPr>
-          <a:lstStyle/>
-          <a:p>
-            <a:pPr algn="l">
-              <a:lnSpc>
-                <a:spcPts val="1200"/>
-              </a:lnSpc>
-              <a:buNone/>
-            </a:pPr>
-            <a:r>
-              <a:rPr lang="en-US" sz="940" dirty="0" b="1">
-                <a:solidFill>
-                  <a:srgbClr val="8C8C8C"/>
-                </a:solidFill>
-                <a:latin typeface="Consolas"/>
-                <a:cs typeface="Consolas"/>
-              </a:rPr>
-              <a:t>5/8</a:t>
-            </a:r>
-          </a:p>
-        </p:txBody>
-      </p:sp>
-      <p:sp>
-        <p:nvSpPr>
-          <p:cNvPr id="19" name="text19"/>
-          <p:cNvSpPr txBox="1"/>
-          <p:nvPr/>
-        </p:nvSpPr>
-        <p:spPr>
-          <a:xfrm>
-            <a:off x="6908800" y="3327400"/>
-            <a:ext cx="1219200" cy="203200"/>
-          </a:xfrm>
-          <a:prstGeom prst="rect">
-            <a:avLst/>
-          </a:prstGeom>
-          <a:noFill/>
-          <a:ln>
-            <a:noFill/>
-          </a:ln>
-        </p:spPr>
-        <p:txBody>
-          <a:bodyPr wrap="square" lIns="0" tIns="0" rIns="0" bIns="0" anchor="t">
-            <a:noAutofit/>
-          </a:bodyPr>
-          <a:lstStyle/>
-          <a:p>
-            <a:pPr algn="l">
-              <a:lnSpc>
-                <a:spcPts val="1200"/>
-              </a:lnSpc>
-              <a:buNone/>
-            </a:pPr>
-            <a:r>
-              <a:rPr lang="en-US" sz="940" dirty="0">
-                <a:solidFill>
-                  <a:srgbClr val="C9C9C9"/>
-                </a:solidFill>
-                <a:latin typeface="Segoe UI"/>
-                <a:cs typeface="Segoe UI"/>
-              </a:rPr>
-              <a:t>baseline 2</a:t>
-            </a:r>
-          </a:p>
-        </p:txBody>
-      </p:sp>
-      <p:sp>
-        <p:nvSpPr>
-          <p:cNvPr id="20" name="bar-bg20"/>
-          <p:cNvSpPr txBox="1"/>
-          <p:nvPr/>
-        </p:nvSpPr>
-        <p:spPr>
-          <a:xfrm>
-            <a:off x="8229600" y="3365500"/>
-            <a:ext cx="1905000" cy="127000"/>
-          </a:xfrm>
-          <a:prstGeom prst="rect">
-            <a:avLst/>
-          </a:prstGeom>
-          <a:solidFill>
-            <a:srgbClr val="242424"/>
-          </a:solidFill>
-          <a:ln>
-            <a:noFill/>
-          </a:ln>
-        </p:spPr>
-        <p:txBody>
-          <a:bodyPr wrap="square" lIns="101600" tIns="76200" rIns="101600" bIns="76200" anchor="t">
-            <a:noAutofit/>
-          </a:bodyPr>
-          <a:lstStyle/>
-          <a:p>
-            <a:endParaRPr lang="en-US"/>
-          </a:p>
-        </p:txBody>
-      </p:sp>
-      <p:sp>
-        <p:nvSpPr>
-          <p:cNvPr id="21" name="bar21"/>
-          <p:cNvSpPr txBox="1"/>
-          <p:nvPr/>
-        </p:nvSpPr>
-        <p:spPr>
-          <a:xfrm>
-            <a:off x="8229600" y="3365500"/>
-            <a:ext cx="714375" cy="127000"/>
-          </a:xfrm>
-          <a:prstGeom prst="rect">
-            <a:avLst/>
-          </a:prstGeom>
-          <a:solidFill>
-            <a:srgbClr val="EF4444"/>
-          </a:solidFill>
-          <a:ln>
-            <a:noFill/>
-          </a:ln>
-        </p:spPr>
-        <p:txBody>
-          <a:bodyPr wrap="square" lIns="101600" tIns="76200" rIns="101600" bIns="76200" anchor="t">
-            <a:noAutofit/>
-          </a:bodyPr>
-          <a:lstStyle/>
-          <a:p>
-            <a:endParaRPr lang="en-US"/>
-          </a:p>
-        </p:txBody>
-      </p:sp>
-      <p:sp>
-        <p:nvSpPr>
-          <p:cNvPr id="22" name="text22"/>
-          <p:cNvSpPr txBox="1"/>
-          <p:nvPr/>
-        </p:nvSpPr>
-        <p:spPr>
-          <a:xfrm>
-            <a:off x="10287000" y="3327400"/>
-            <a:ext cx="558800" cy="203200"/>
-          </a:xfrm>
-          <a:prstGeom prst="rect">
-            <a:avLst/>
-          </a:prstGeom>
-          <a:noFill/>
-          <a:ln>
-            <a:noFill/>
-          </a:ln>
-        </p:spPr>
-        <p:txBody>
-          <a:bodyPr wrap="square" lIns="0" tIns="0" rIns="0" bIns="0" anchor="t">
-            <a:noAutofit/>
-          </a:bodyPr>
-          <a:lstStyle/>
-          <a:p>
-            <a:pPr algn="l">
-              <a:lnSpc>
-                <a:spcPts val="1200"/>
-              </a:lnSpc>
-              <a:buNone/>
-            </a:pPr>
-            <a:r>
-              <a:rPr lang="en-US" sz="940" dirty="0" b="1">
-                <a:solidFill>
-                  <a:srgbClr val="8C8C8C"/>
-                </a:solidFill>
-                <a:latin typeface="Consolas"/>
-                <a:cs typeface="Consolas"/>
-              </a:rPr>
-              <a:t>3/8</a:t>
-            </a:r>
-          </a:p>
-        </p:txBody>
-      </p:sp>
-      <p:sp>
-        <p:nvSpPr>
-          <p:cNvPr id="23" name="text23"/>
-          <p:cNvSpPr txBox="1"/>
-          <p:nvPr/>
-        </p:nvSpPr>
-        <p:spPr>
-          <a:xfrm>
-            <a:off x="6908800" y="3759200"/>
-            <a:ext cx="1219200" cy="203200"/>
-          </a:xfrm>
-          <a:prstGeom prst="rect">
-            <a:avLst/>
-          </a:prstGeom>
-          <a:noFill/>
-          <a:ln>
-            <a:noFill/>
-          </a:ln>
-        </p:spPr>
-        <p:txBody>
-          <a:bodyPr wrap="square" lIns="0" tIns="0" rIns="0" bIns="0" anchor="t">
-            <a:noAutofit/>
-          </a:bodyPr>
-          <a:lstStyle/>
-          <a:p>
-            <a:pPr algn="l">
-              <a:lnSpc>
-                <a:spcPts val="1200"/>
-              </a:lnSpc>
-              <a:buNone/>
-            </a:pPr>
-            <a:r>
-              <a:rPr lang="en-US" sz="940" dirty="0">
-                <a:solidFill>
-                  <a:srgbClr val="C9C9C9"/>
-                </a:solidFill>
-                <a:latin typeface="Segoe UI"/>
-                <a:cs typeface="Segoe UI"/>
-              </a:rPr>
-              <a:t>baseline 3</a:t>
-            </a:r>
-          </a:p>
-        </p:txBody>
-      </p:sp>
-      <p:sp>
-        <p:nvSpPr>
-          <p:cNvPr id="24" name="bar-bg24"/>
-          <p:cNvSpPr txBox="1"/>
-          <p:nvPr/>
-        </p:nvSpPr>
-        <p:spPr>
-          <a:xfrm>
-            <a:off x="8229600" y="3797300"/>
-            <a:ext cx="1905000" cy="127000"/>
-          </a:xfrm>
-          <a:prstGeom prst="rect">
-            <a:avLst/>
-          </a:prstGeom>
-          <a:solidFill>
-            <a:srgbClr val="242424"/>
-          </a:solidFill>
-          <a:ln>
-            <a:noFill/>
-          </a:ln>
-        </p:spPr>
-        <p:txBody>
-          <a:bodyPr wrap="square" lIns="101600" tIns="76200" rIns="101600" bIns="76200" anchor="t">
-            <a:noAutofit/>
-          </a:bodyPr>
-          <a:lstStyle/>
-          <a:p>
-            <a:endParaRPr lang="en-US"/>
-          </a:p>
-        </p:txBody>
-      </p:sp>
-      <p:sp>
-        <p:nvSpPr>
-          <p:cNvPr id="25" name="bar25"/>
-          <p:cNvSpPr txBox="1"/>
-          <p:nvPr/>
-        </p:nvSpPr>
-        <p:spPr>
-          <a:xfrm>
-            <a:off x="8229600" y="3797300"/>
-            <a:ext cx="1428750" cy="127000"/>
-          </a:xfrm>
-          <a:prstGeom prst="rect">
-            <a:avLst/>
-          </a:prstGeom>
-          <a:solidFill>
-            <a:srgbClr val="EF4444"/>
-          </a:solidFill>
-          <a:ln>
-            <a:noFill/>
-          </a:ln>
-        </p:spPr>
-        <p:txBody>
-          <a:bodyPr wrap="square" lIns="101600" tIns="76200" rIns="101600" bIns="76200" anchor="t">
-            <a:noAutofit/>
-          </a:bodyPr>
-          <a:lstStyle/>
-          <a:p>
-            <a:endParaRPr lang="en-US"/>
-          </a:p>
-        </p:txBody>
-      </p:sp>
-      <p:sp>
-        <p:nvSpPr>
-          <p:cNvPr id="26" name="text26"/>
-          <p:cNvSpPr txBox="1"/>
-          <p:nvPr/>
-        </p:nvSpPr>
-        <p:spPr>
-          <a:xfrm>
-            <a:off x="10287000" y="3759200"/>
-            <a:ext cx="558800" cy="203200"/>
-          </a:xfrm>
-          <a:prstGeom prst="rect">
-            <a:avLst/>
-          </a:prstGeom>
-          <a:noFill/>
-          <a:ln>
-            <a:noFill/>
-          </a:ln>
-        </p:spPr>
-        <p:txBody>
-          <a:bodyPr wrap="square" lIns="0" tIns="0" rIns="0" bIns="0" anchor="t">
-            <a:noAutofit/>
-          </a:bodyPr>
-          <a:lstStyle/>
-          <a:p>
-            <a:pPr algn="l">
-              <a:lnSpc>
-                <a:spcPts val="1200"/>
-              </a:lnSpc>
-              <a:buNone/>
-            </a:pPr>
-            <a:r>
-              <a:rPr lang="en-US" sz="940" dirty="0" b="1">
-                <a:solidFill>
-                  <a:srgbClr val="8C8C8C"/>
-                </a:solidFill>
-                <a:latin typeface="Consolas"/>
-                <a:cs typeface="Consolas"/>
-              </a:rPr>
-              <a:t>6/8</a:t>
-            </a:r>
-          </a:p>
-        </p:txBody>
-      </p:sp>
-      <p:sp>
-        <p:nvSpPr>
-          <p:cNvPr id="27" name="rule27"/>
-          <p:cNvSpPr txBox="1"/>
-          <p:nvPr/>
-        </p:nvSpPr>
-        <p:spPr>
-          <a:xfrm>
-            <a:off x="6908800" y="4318000"/>
-            <a:ext cx="4343400" cy="12700"/>
-          </a:xfrm>
-          <a:prstGeom prst="rect">
-            <a:avLst/>
-          </a:prstGeom>
-          <a:solidFill>
-            <a:srgbClr val="242424"/>
-          </a:solidFill>
-          <a:ln>
-            <a:noFill/>
-          </a:ln>
-        </p:spPr>
-        <p:txBody>
-          <a:bodyPr wrap="square" lIns="101600" tIns="76200" rIns="101600" bIns="76200" anchor="t">
-            <a:noAutofit/>
-          </a:bodyPr>
-          <a:lstStyle/>
-          <a:p>
-            <a:endParaRPr lang="en-US"/>
-          </a:p>
-        </p:txBody>
-      </p:sp>
-      <p:sp>
-        <p:nvSpPr>
-          <p:cNvPr id="28" name="text28"/>
-          <p:cNvSpPr txBox="1"/>
-          <p:nvPr/>
-        </p:nvSpPr>
-        <p:spPr>
-          <a:xfrm>
-            <a:off x="6908800" y="4521200"/>
-            <a:ext cx="4343400" cy="1371600"/>
-          </a:xfrm>
-          <a:prstGeom prst="rect">
-            <a:avLst/>
-          </a:prstGeom>
-          <a:noFill/>
-          <a:ln>
-            <a:noFill/>
-          </a:ln>
-        </p:spPr>
-        <p:txBody>
-          <a:bodyPr wrap="square" lIns="0" tIns="0" rIns="0" bIns="0" anchor="t">
-            <a:noAutofit/>
-          </a:bodyPr>
-          <a:lstStyle/>
-          <a:p>
-            <a:pPr algn="l">
-              <a:lnSpc>
-                <a:spcPts val="1278"/>
-              </a:lnSpc>
-              <a:buNone/>
-            </a:pPr>
-            <a:r>
-              <a:rPr lang="en-US" sz="900" dirty="0" b="1">
-                <a:solidFill>
-                  <a:srgbClr val="4ADE80"/>
-                </a:solidFill>
-                <a:latin typeface="Segoe UI"/>
-                <a:cs typeface="Segoe UI"/>
-              </a:rPr>
-              <a:t>How a phase is counted</a:t>
-            </a:r>
-          </a:p>
-          <a:p>
-            <a:pPr algn="l">
-              <a:lnSpc>
-                <a:spcPts val="1278"/>
+              <a:t>Real-number identities and chain ordering are permitted with --fp-algebraic.</a:t>
+            </a:r>
+          </a:p>
+          <a:p>
+            <a:pPr algn="l">
+              <a:lnSpc>
+                <a:spcPts val="1562"/>
               </a:lnSpc>
               <a:spcBef>
                 <a:spcPts val="900"/>
@@ -2785,21 +1972,86 @@
               <a:buNone/>
             </a:pPr>
             <a:r>
-              <a:rPr lang="en-US" sz="900" dirty="0">
+              <a:rPr lang="en-US" sz="1100" dirty="0">
                 <a:solidFill>
                   <a:srgbClr val="8C8C8C"/>
                 </a:solidFill>
                 <a:latin typeface="Segoe UI"/>
                 <a:cs typeface="Segoe UI"/>
               </a:rPr>
-              <a:t>A file is attributed to a phase by its path and name, and a phase counts as present on a single case-insensitive match of any marker. The rule can only overstate a baseline, and it still finds no optimizer in any of them.</a:t>
-            </a:r>
-          </a:p>
-        </p:txBody>
-      </p:sp>
-      <p:sp>
-        <p:nvSpPr>
-          <p:cNvPr id="29" name="text29"/>
+              <a:t>Floating-point output can differ. Shape correctness is still required; there is no error-bound guarantee.</a:t>
+            </a:r>
+          </a:p>
+        </p:txBody>
+      </p:sp>
+      <p:sp>
+        <p:nvSpPr>
+          <p:cNvPr id="8" name="text8"/>
+          <p:cNvSpPr txBox="1"/>
+          <p:nvPr/>
+        </p:nvSpPr>
+        <p:spPr>
+          <a:xfrm>
+            <a:off x="711200" y="5524500"/>
+            <a:ext cx="10769600" cy="952500"/>
+          </a:xfrm>
+          <a:prstGeom prst="rect">
+            <a:avLst/>
+          </a:prstGeom>
+          <a:noFill/>
+          <a:ln>
+            <a:noFill/>
+          </a:ln>
+        </p:spPr>
+        <p:txBody>
+          <a:bodyPr wrap="square" lIns="0" tIns="0" rIns="0" bIns="0" anchor="t">
+            <a:noAutofit/>
+          </a:bodyPr>
+          <a:lstStyle/>
+          <a:p>
+            <a:pPr algn="l">
+              <a:lnSpc>
+                <a:spcPts val="1562"/>
+              </a:lnSpc>
+              <a:buNone/>
+            </a:pPr>
+            <a:r>
+              <a:rPr lang="en-US" sz="1100" dirty="0">
+                <a:solidFill>
+                  <a:srgbClr val="6E9BFF"/>
+                </a:solidFill>
+                <a:latin typeface="Segoe UI"/>
+                <a:cs typeface="Segoe UI"/>
+              </a:rPr>
+              <a:t>The paper evaluates ten seeds, eight arms and five workload profiles. This lab deck retains the two-seed development results.</a:t>
+            </a:r>
+          </a:p>
+          <a:p>
+            <a:pPr algn="l">
+              <a:lnSpc>
+                <a:spcPts val="1420"/>
+              </a:lnSpc>
+              <a:spcBef>
+                <a:spcPts val="900"/>
+              </a:spcBef>
+              <a:buNone/>
+            </a:pPr>
+            <a:r>
+              <a:rPr lang="en-US" sz="1000" dirty="0">
+                <a:solidFill>
+                  <a:srgbClr val="8C8C8C"/>
+                </a:solidFill>
+                <a:latin typeface="Segoe UI"/>
+                <a:cs typeface="Segoe UI"/>
+              </a:rPr>
+              <a:t>Repository marker counts do not verify implementations and are excluded from research evidence.</a:t>
+            </a:r>
+          </a:p>
+        </p:txBody>
+      </p:sp>
+      <p:sp>
+        <p:nvSpPr>
+          <p:cNvPr id="9" name="text9"/>
           <p:cNvSpPr txBox="1"/>
           <p:nvPr/>
         </p:nvSpPr>
@@ -3889,7 +3141,7 @@
                 <a:latin typeface="Segoe UI"/>
                 <a:cs typeface="Segoe UI"/>
               </a:rPr>
-              <a:t>No control flow. That is the enabling decision, not a gap.</a:t>
+              <a:t>No control flow: a deliberate limit on project scope.</a:t>
             </a:r>
           </a:p>
         </p:txBody>
@@ -4030,7 +3282,7 @@
                 <a:latin typeface="Segoe UI"/>
                 <a:cs typeface="Segoe UI"/>
               </a:rPr>
-              <a:t>A course reaches working CSE and dead-code elimination without first building a control-flow graph, which is where a semester usually runs out.</a:t>
+              <a:t>CSE and dead-code elimination can be inspected without a control-flow graph. The artifact does not teach inter-block analysis.</a:t>
             </a:r>
           </a:p>
         </p:txBody>
@@ -5979,7 +5231,7 @@
                 <a:latin typeface="Segoe UI"/>
                 <a:cs typeface="Segoe UI"/>
               </a:rPr>
-              <a:t>Multiplying an m x n by an n x p matrix performs m p (2n-1) operations. Every term is a shape, and every shape is in the type.</a:t>
+              <a:t>The conventional dense-product model counts m p (2n-1) scalar operations. This is a static arithmetic objective, not a measurement of VM runtime.</a:t>
             </a:r>
           </a:p>
         </p:txBody>
@@ -6407,7 +5659,7 @@
                 <a:latin typeface="Consolas"/>
                 <a:cs typeface="Consolas"/>
               </a:rPr>
-              <a:t>Matrix multiplication is associative: both compute the same</a:t>
+              <a:t>Over real numbers multiplication is associative; floating-point</a:t>
             </a:r>
           </a:p>
           <a:p>
@@ -6425,7 +5677,7 @@
                 <a:latin typeface="Consolas"/>
                 <a:cs typeface="Consolas"/>
               </a:rPr>
-              <a:t>matrix. Which is cheaper depends only on the shapes.</a:t>
+              <a:t>output can change. Reassociation requires --fp-algebraic.</a:t>
             </a:r>
           </a:p>
         </p:txBody>
@@ -6707,7 +5959,7 @@
                 <a:latin typeface="Segoe UI"/>
                 <a:cs typeface="Segoe UI"/>
               </a:rPr>
-              <a:t>What is new is that a student compiler holds the information needed to run it.</a:t>
+              <a:t>The teaching artifact connects this established algorithm to shape checking and numerical contracts.</a:t>
             </a:r>
           </a:p>
         </p:txBody>
@@ -6895,7 +6147,7 @@
                 <a:latin typeface="Segoe UI"/>
                 <a:cs typeface="Segoe UI"/>
               </a:rPr>
-              <a:t>400 programs from a generator, across two seeds. The corpus was not written by whoever wrote the optimizer.</a:t>
+              <a:t>400 development programs across two seeds. Cost uses algebraic mode; execution uses strict mode. The paper reports the separate ten-seed evaluation.</a:t>
             </a:r>
           </a:p>
         </p:txBody>
@@ -7884,7 +7136,7 @@
                 <a:latin typeface="Segoe UI"/>
                 <a:cs typeface="Segoe UI"/>
               </a:rPr>
-              <a:t>programs printed identical bytes with</a:t>
+              <a:t>strict programs printed identical bytes</a:t>
             </a:r>
           </a:p>
           <a:p>
@@ -7902,7 +7154,7 @@
                 <a:latin typeface="Segoe UI"/>
                 <a:cs typeface="Segoe UI"/>
               </a:rPr>
-              <a:t>the optimizer and without</a:t>
+              <a:t>with the optimizer and without</a:t>
             </a:r>
           </a:p>
         </p:txBody>
@@ -7977,7 +7229,7 @@
                 <a:latin typeface="Segoe UI"/>
                 <a:cs typeface="Segoe UI"/>
               </a:rPr>
-              <a:t>Not one lucky corpus.   </a:t>
+              <a:t>Development seeds.   </a:t>
             </a:r>
             <a:r>
               <a:rPr lang="en-US" sz="960" dirty="0">
@@ -8633,7 +7885,7 @@
                 <a:latin typeface="Segoe UI"/>
                 <a:cs typeface="Segoe UI"/>
               </a:rPr>
-              <a:t>A finding about what a course can afford.</a:t>
+              <a:t>A regression target for the artifact.</a:t>
             </a:r>
           </a:p>
           <a:p>
@@ -8654,7 +7906,7 @@
                 <a:latin typeface="Segoe UI"/>
                 <a:cs typeface="Segoe UI"/>
               </a:rPr>
-              <a:t>A generator and a loop comparing two runs, which is a weekend of work, found a defect in a student-scale optimizer that reading the code had not, on an input nobody chose.</a:t>
+              <a:t>Generated comparisons motivated explicit strict and algebraic contracts. Fifteen numerical fixtures now check signed zeros, overflow, reassociation and mutable names.</a:t>
             </a:r>
           </a:p>
         </p:txBody>
@@ -8886,7 +8138,7 @@
                 <a:latin typeface="Segoe UI"/>
                 <a:cs typeface="Segoe UI"/>
               </a:rPr>
-              <a:t>It decides which phases can carry real work. That is the claim, and it is the one we can evidence.</a:t>
+              <a:t>MatrixLang connects shape checking, modeled cost and rewrite legality. Its proposed exercises have not been evaluated with students.</a:t>
             </a:r>
           </a:p>
         </p:txBody>
@@ -9674,7 +8926,7 @@
                 <a:latin typeface="Segoe UI"/>
                 <a:cs typeface="Segoe UI"/>
               </a:rPr>
-              <a:t>Whatever the domain, if the type system carries enough to cost a program statically, a student's optimizer can be scored on the work it removes rather than the lines it removes. The two are not close.</a:t>
+              <a:t>Use both metrics and state the numerical contract. Shape and expression controls show where chain savings disappear; exact output comparisons show where algebraic transformations change behavior.</a:t>
             </a:r>
           </a:p>
         </p:txBody>

</xml_diff>